<commit_message>
Add visuals and traction to deck
</commit_message>
<xml_diff>
--- a/HomeWard_DevFest_Winning_Pitch_Deck.pptx
+++ b/HomeWard_DevFest_Winning_Pitch_Deck.pptx
@@ -1676,9 +1676,62 @@
           <a:chExt cx="0" cy="0"/>
         </a:xfrm>
       </p:grpSpPr>
-      <p:sp>
-        <p:nvSpPr>
-          <p:cNvPr id="2" name="Shape 0"/>
+      <p:pic>
+        <p:nvPicPr>
+          <p:cNvPr id="2" name="Image 0" descr="C:/Users/Raheem/Desktop/Twala/homeward-diaspora-hero.png">    </p:cNvPr>
+          <p:cNvPicPr>
+            <a:picLocks noChangeAspect="1"/>
+          </p:cNvPicPr>
+          <p:nvPr/>
+        </p:nvPicPr>
+        <p:blipFill>
+          <a:blip r:embed="rId1"/>
+          <a:stretch>
+            <a:fillRect/>
+          </a:stretch>
+        </p:blipFill>
+        <p:spPr>
+          <a:xfrm>
+            <a:off x="0" y="0"/>
+            <a:ext cx="12191695" cy="6858000"/>
+          </a:xfrm>
+          <a:prstGeom prst="rect">
+            <a:avLst/>
+          </a:prstGeom>
+        </p:spPr>
+      </p:pic>
+      <p:sp>
+        <p:nvSpPr>
+          <p:cNvPr id="3" name="Shape 0"/>
+          <p:cNvSpPr/>
+          <p:nvPr/>
+        </p:nvSpPr>
+        <p:spPr>
+          <a:xfrm>
+            <a:off x="0" y="0"/>
+            <a:ext cx="7498080" cy="6858000"/>
+          </a:xfrm>
+          <a:prstGeom prst="rect">
+            <a:avLst/>
+          </a:prstGeom>
+          <a:solidFill>
+            <a:srgbClr val="061E25">
+              <a:alpha val="95000"/>
+            </a:srgbClr>
+          </a:solidFill>
+          <a:ln w="12700">
+            <a:solidFill>
+              <a:srgbClr val="061E25">
+                <a:alpha val="0"/>
+              </a:srgbClr>
+            </a:solidFill>
+            <a:prstDash val="solid"/>
+          </a:ln>
+        </p:spPr>
+      </p:sp>
+      <p:sp>
+        <p:nvSpPr>
+          <p:cNvPr id="4" name="Shape 1"/>
           <p:cNvSpPr/>
           <p:nvPr/>
         </p:nvSpPr>
@@ -1707,7 +1760,7 @@
       </p:sp>
       <p:sp>
         <p:nvSpPr>
-          <p:cNvPr id="3" name="Shape 1"/>
+          <p:cNvPr id="5" name="Shape 2"/>
           <p:cNvSpPr/>
           <p:nvPr/>
         </p:nvSpPr>
@@ -1736,7 +1789,7 @@
       </p:sp>
       <p:sp>
         <p:nvSpPr>
-          <p:cNvPr id="4" name="Shape 2"/>
+          <p:cNvPr id="6" name="Shape 3"/>
           <p:cNvSpPr/>
           <p:nvPr/>
         </p:nvSpPr>
@@ -1765,7 +1818,7 @@
       </p:sp>
       <p:sp>
         <p:nvSpPr>
-          <p:cNvPr id="5" name="Text 3"/>
+          <p:cNvPr id="7" name="Text 4"/>
           <p:cNvSpPr/>
           <p:nvPr/>
         </p:nvSpPr>
@@ -1806,7 +1859,7 @@
       </p:sp>
       <p:sp>
         <p:nvSpPr>
-          <p:cNvPr id="6" name="Text 4"/>
+          <p:cNvPr id="8" name="Text 5"/>
           <p:cNvSpPr/>
           <p:nvPr/>
         </p:nvSpPr>
@@ -1864,7 +1917,7 @@
       </p:sp>
       <p:sp>
         <p:nvSpPr>
-          <p:cNvPr id="7" name="Text 5"/>
+          <p:cNvPr id="9" name="Text 6"/>
           <p:cNvSpPr/>
           <p:nvPr/>
         </p:nvSpPr>
@@ -1905,7 +1958,7 @@
       </p:sp>
       <p:sp>
         <p:nvSpPr>
-          <p:cNvPr id="8" name="Text 6"/>
+          <p:cNvPr id="10" name="Text 7"/>
           <p:cNvSpPr/>
           <p:nvPr/>
         </p:nvSpPr>
@@ -1963,7 +2016,7 @@
       </p:sp>
       <p:sp>
         <p:nvSpPr>
-          <p:cNvPr id="9" name="Shape 7"/>
+          <p:cNvPr id="11" name="Shape 8"/>
           <p:cNvSpPr/>
           <p:nvPr/>
         </p:nvSpPr>
@@ -1992,7 +2045,7 @@
       </p:sp>
       <p:sp>
         <p:nvSpPr>
-          <p:cNvPr id="10" name="Text 8"/>
+          <p:cNvPr id="12" name="Text 9"/>
           <p:cNvSpPr/>
           <p:nvPr/>
         </p:nvSpPr>
@@ -2050,7 +2103,7 @@
       </p:sp>
       <p:sp>
         <p:nvSpPr>
-          <p:cNvPr id="11" name="Text 9"/>
+          <p:cNvPr id="13" name="Text 10"/>
           <p:cNvSpPr/>
           <p:nvPr/>
         </p:nvSpPr>
@@ -2091,7 +2144,7 @@
       </p:sp>
       <p:sp>
         <p:nvSpPr>
-          <p:cNvPr id="12" name="Text 10"/>
+          <p:cNvPr id="14" name="Text 11"/>
           <p:cNvSpPr/>
           <p:nvPr/>
         </p:nvSpPr>
@@ -8568,7 +8621,7 @@
                 <a:ea typeface="Aptos" pitchFamily="34" charset="-122"/>
                 <a:cs typeface="Aptos" pitchFamily="34" charset="-120"/>
               </a:rPr>
-              <a:t>WHY HOMEWARD CAN WIN</a:t>
+              <a:t>TRACTION</a:t>
             </a:r>
             <a:endParaRPr lang="en-US" sz="850" dirty="0"/>
           </a:p>
@@ -8609,7 +8662,7 @@
                 <a:ea typeface="Aptos" pitchFamily="34" charset="-122"/>
                 <a:cs typeface="Aptos" pitchFamily="34" charset="-120"/>
               </a:rPr>
-              <a:t>Not another wallet. A family-support operating system.</a:t>
+              <a:t>We have shipped proof - not just a concept.</a:t>
             </a:r>
             <a:endParaRPr lang="en-US" sz="2700" dirty="0"/>
           </a:p>
@@ -8617,7 +8670,48 @@
       </p:sp>
       <p:sp>
         <p:nvSpPr>
-          <p:cNvPr id="4" name="Shape 2"/>
+          <p:cNvPr id="4" name="Text 2"/>
+          <p:cNvSpPr/>
+          <p:nvPr/>
+        </p:nvSpPr>
+        <p:spPr>
+          <a:xfrm>
+            <a:off x="658368" y="1353312"/>
+            <a:ext cx="10332720" cy="310896"/>
+          </a:xfrm>
+          <a:prstGeom prst="rect">
+            <a:avLst/>
+          </a:prstGeom>
+          <a:noFill/>
+          <a:ln/>
+        </p:spPr>
+        <p:txBody>
+          <a:bodyPr wrap="square" lIns="0" tIns="0" rIns="0" bIns="0" rtlCol="0" anchor="ctr">
+            <a:normAutofit/>
+          </a:bodyPr>
+          <a:lstStyle/>
+          <a:p>
+            <a:pPr algn="l" indent="0" marL="0">
+              <a:buNone/>
+            </a:pPr>
+            <a:r>
+              <a:rPr lang="en-US" sz="1250" dirty="0">
+                <a:solidFill>
+                  <a:srgbClr val="60767A"/>
+                </a:solidFill>
+                <a:latin typeface="Aptos" pitchFamily="34" charset="0"/>
+                <a:ea typeface="Aptos" pitchFamily="34" charset="-122"/>
+                <a:cs typeface="Aptos" pitchFamily="34" charset="-120"/>
+              </a:rPr>
+              <a:t>We are deliberately reporting product evidence instead of inventing user-growth numbers before a regulated pilot.</a:t>
+            </a:r>
+            <a:endParaRPr lang="en-US" sz="1250" dirty="0"/>
+          </a:p>
+        </p:txBody>
+      </p:sp>
+      <p:sp>
+        <p:nvSpPr>
+          <p:cNvPr id="5" name="Shape 3"/>
           <p:cNvSpPr/>
           <p:nvPr/>
         </p:nvSpPr>
@@ -8640,170 +8734,18 @@
       </p:sp>
       <p:sp>
         <p:nvSpPr>
-          <p:cNvPr id="5" name="Shape 3"/>
-          <p:cNvSpPr/>
-          <p:nvPr/>
-        </p:nvSpPr>
-        <p:spPr>
-          <a:xfrm>
-            <a:off x="685800" y="2194560"/>
-            <a:ext cx="10789920" cy="475488"/>
+          <p:cNvPr id="6" name="Shape 4"/>
+          <p:cNvSpPr/>
+          <p:nvPr/>
+        </p:nvSpPr>
+        <p:spPr>
+          <a:xfrm>
+            <a:off x="685800" y="2240280"/>
+            <a:ext cx="5102352" cy="1097280"/>
           </a:xfrm>
           <a:prstGeom prst="roundRect">
             <a:avLst>
-              <a:gd name="adj" fmla="val 30769"/>
-            </a:avLst>
-          </a:prstGeom>
-          <a:solidFill>
-            <a:srgbClr val="063A45"/>
-          </a:solidFill>
-          <a:ln w="12700">
-            <a:solidFill>
-              <a:srgbClr val="063A45">
-                <a:alpha val="0"/>
-              </a:srgbClr>
-            </a:solidFill>
-            <a:prstDash val="solid"/>
-          </a:ln>
-        </p:spPr>
-      </p:sp>
-      <p:sp>
-        <p:nvSpPr>
-          <p:cNvPr id="6" name="Text 4"/>
-          <p:cNvSpPr/>
-          <p:nvPr/>
-        </p:nvSpPr>
-        <p:spPr>
-          <a:xfrm>
-            <a:off x="914400" y="2350008"/>
-            <a:ext cx="2194560" cy="146304"/>
-          </a:xfrm>
-          <a:prstGeom prst="rect">
-            <a:avLst/>
-          </a:prstGeom>
-          <a:noFill/>
-          <a:ln/>
-        </p:spPr>
-        <p:txBody>
-          <a:bodyPr wrap="square" lIns="0" tIns="0" rIns="0" bIns="0" rtlCol="0" anchor="ctr">
-            <a:normAutofit/>
-          </a:bodyPr>
-          <a:lstStyle/>
-          <a:p>
-            <a:pPr algn="l" indent="0" marL="0">
-              <a:buNone/>
-            </a:pPr>
-            <a:r>
-              <a:rPr lang="en-US" sz="950" b="1" spc="70" kern="0" dirty="0">
-                <a:solidFill>
-                  <a:srgbClr val="FFFFFF"/>
-                </a:solidFill>
-                <a:latin typeface="Aptos" pitchFamily="34" charset="0"/>
-                <a:ea typeface="Aptos" pitchFamily="34" charset="-122"/>
-                <a:cs typeface="Aptos" pitchFamily="34" charset="-120"/>
-              </a:rPr>
-              <a:t>MOMENT</a:t>
-            </a:r>
-            <a:endParaRPr lang="en-US" sz="950" dirty="0"/>
-          </a:p>
-        </p:txBody>
-      </p:sp>
-      <p:sp>
-        <p:nvSpPr>
-          <p:cNvPr id="7" name="Text 5"/>
-          <p:cNvSpPr/>
-          <p:nvPr/>
-        </p:nvSpPr>
-        <p:spPr>
-          <a:xfrm>
-            <a:off x="3749040" y="2350008"/>
-            <a:ext cx="2468880" cy="146304"/>
-          </a:xfrm>
-          <a:prstGeom prst="rect">
-            <a:avLst/>
-          </a:prstGeom>
-          <a:noFill/>
-          <a:ln/>
-        </p:spPr>
-        <p:txBody>
-          <a:bodyPr wrap="square" lIns="0" tIns="0" rIns="0" bIns="0" rtlCol="0" anchor="ctr">
-            <a:normAutofit/>
-          </a:bodyPr>
-          <a:lstStyle/>
-          <a:p>
-            <a:pPr algn="l" indent="0" marL="0">
-              <a:buNone/>
-            </a:pPr>
-            <a:r>
-              <a:rPr lang="en-US" sz="950" b="1" spc="70" kern="0" dirty="0">
-                <a:solidFill>
-                  <a:srgbClr val="FFFFFF"/>
-                </a:solidFill>
-                <a:latin typeface="Aptos" pitchFamily="34" charset="0"/>
-                <a:ea typeface="Aptos" pitchFamily="34" charset="-122"/>
-                <a:cs typeface="Aptos" pitchFamily="34" charset="-120"/>
-              </a:rPr>
-              <a:t>TYPICAL EXPERIENCE</a:t>
-            </a:r>
-            <a:endParaRPr lang="en-US" sz="950" dirty="0"/>
-          </a:p>
-        </p:txBody>
-      </p:sp>
-      <p:sp>
-        <p:nvSpPr>
-          <p:cNvPr id="8" name="Text 6"/>
-          <p:cNvSpPr/>
-          <p:nvPr/>
-        </p:nvSpPr>
-        <p:spPr>
-          <a:xfrm>
-            <a:off x="7498080" y="2350008"/>
-            <a:ext cx="2743200" cy="146304"/>
-          </a:xfrm>
-          <a:prstGeom prst="rect">
-            <a:avLst/>
-          </a:prstGeom>
-          <a:noFill/>
-          <a:ln/>
-        </p:spPr>
-        <p:txBody>
-          <a:bodyPr wrap="square" lIns="0" tIns="0" rIns="0" bIns="0" rtlCol="0" anchor="ctr">
-            <a:normAutofit/>
-          </a:bodyPr>
-          <a:lstStyle/>
-          <a:p>
-            <a:pPr algn="l" indent="0" marL="0">
-              <a:buNone/>
-            </a:pPr>
-            <a:r>
-              <a:rPr lang="en-US" sz="950" b="1" spc="70" kern="0" dirty="0">
-                <a:solidFill>
-                  <a:srgbClr val="FFFFFF"/>
-                </a:solidFill>
-                <a:latin typeface="Aptos" pitchFamily="34" charset="0"/>
-                <a:ea typeface="Aptos" pitchFamily="34" charset="-122"/>
-                <a:cs typeface="Aptos" pitchFamily="34" charset="-120"/>
-              </a:rPr>
-              <a:t>HOMEWARD DIFFERENCE</a:t>
-            </a:r>
-            <a:endParaRPr lang="en-US" sz="950" dirty="0"/>
-          </a:p>
-        </p:txBody>
-      </p:sp>
-      <p:sp>
-        <p:nvSpPr>
-          <p:cNvPr id="9" name="Shape 7"/>
-          <p:cNvSpPr/>
-          <p:nvPr/>
-        </p:nvSpPr>
-        <p:spPr>
-          <a:xfrm>
-            <a:off x="685800" y="2743200"/>
-            <a:ext cx="10789920" cy="566928"/>
-          </a:xfrm>
-          <a:prstGeom prst="roundRect">
-            <a:avLst>
-              <a:gd name="adj" fmla="val 25806"/>
+              <a:gd name="adj" fmla="val 13333"/>
             </a:avLst>
           </a:prstGeom>
           <a:solidFill>
@@ -8821,149 +8763,26 @@
       </p:sp>
       <p:sp>
         <p:nvSpPr>
-          <p:cNvPr id="10" name="Text 8"/>
-          <p:cNvSpPr/>
-          <p:nvPr/>
-        </p:nvSpPr>
-        <p:spPr>
-          <a:xfrm>
-            <a:off x="914400" y="2907792"/>
-            <a:ext cx="2103120" cy="164592"/>
-          </a:xfrm>
-          <a:prstGeom prst="rect">
-            <a:avLst/>
-          </a:prstGeom>
-          <a:noFill/>
-          <a:ln/>
-        </p:spPr>
-        <p:txBody>
-          <a:bodyPr wrap="square" lIns="0" tIns="0" rIns="0" bIns="0" rtlCol="0" anchor="ctr">
-            <a:normAutofit/>
-          </a:bodyPr>
-          <a:lstStyle/>
-          <a:p>
-            <a:pPr algn="l" indent="0" marL="0">
-              <a:buNone/>
-            </a:pPr>
-            <a:r>
-              <a:rPr lang="en-US" sz="1150" b="1" dirty="0">
-                <a:solidFill>
-                  <a:srgbClr val="063A45"/>
-                </a:solidFill>
-                <a:latin typeface="Aptos" pitchFamily="34" charset="0"/>
-                <a:ea typeface="Aptos" pitchFamily="34" charset="-122"/>
-                <a:cs typeface="Aptos" pitchFamily="34" charset="-120"/>
-              </a:rPr>
-              <a:t>Before sending</a:t>
-            </a:r>
-            <a:endParaRPr lang="en-US" sz="1150" dirty="0"/>
-          </a:p>
-        </p:txBody>
-      </p:sp>
-      <p:sp>
-        <p:nvSpPr>
-          <p:cNvPr id="11" name="Text 9"/>
-          <p:cNvSpPr/>
-          <p:nvPr/>
-        </p:nvSpPr>
-        <p:spPr>
-          <a:xfrm>
-            <a:off x="3749040" y="2907792"/>
-            <a:ext cx="3017520" cy="164592"/>
-          </a:xfrm>
-          <a:prstGeom prst="rect">
-            <a:avLst/>
-          </a:prstGeom>
-          <a:noFill/>
-          <a:ln/>
-        </p:spPr>
-        <p:txBody>
-          <a:bodyPr wrap="square" lIns="0" tIns="0" rIns="0" bIns="0" rtlCol="0" anchor="ctr">
-            <a:normAutofit/>
-          </a:bodyPr>
-          <a:lstStyle/>
-          <a:p>
-            <a:pPr algn="l" indent="0" marL="0">
-              <a:buNone/>
-            </a:pPr>
-            <a:r>
-              <a:rPr lang="en-US" sz="1080" dirty="0">
-                <a:solidFill>
-                  <a:srgbClr val="60767A"/>
-                </a:solidFill>
-                <a:latin typeface="Aptos" pitchFamily="34" charset="0"/>
-                <a:ea typeface="Aptos" pitchFamily="34" charset="-122"/>
-                <a:cs typeface="Aptos" pitchFamily="34" charset="-120"/>
-              </a:rPr>
-              <a:t>Recipient + amount anxiety</a:t>
-            </a:r>
-            <a:endParaRPr lang="en-US" sz="1080" dirty="0"/>
-          </a:p>
-        </p:txBody>
-      </p:sp>
-      <p:sp>
-        <p:nvSpPr>
-          <p:cNvPr id="12" name="Text 10"/>
-          <p:cNvSpPr/>
-          <p:nvPr/>
-        </p:nvSpPr>
-        <p:spPr>
-          <a:xfrm>
-            <a:off x="7498080" y="2889504"/>
-            <a:ext cx="3383280" cy="201168"/>
-          </a:xfrm>
-          <a:prstGeom prst="rect">
-            <a:avLst/>
-          </a:prstGeom>
-          <a:noFill/>
-          <a:ln/>
-        </p:spPr>
-        <p:txBody>
-          <a:bodyPr wrap="square" lIns="0" tIns="0" rIns="0" bIns="0" rtlCol="0" anchor="ctr">
-            <a:normAutofit/>
-          </a:bodyPr>
-          <a:lstStyle/>
-          <a:p>
-            <a:pPr algn="l" indent="0" marL="0">
-              <a:buNone/>
-            </a:pPr>
-            <a:r>
-              <a:rPr lang="en-US" sz="1080" b="1" dirty="0">
-                <a:solidFill>
-                  <a:srgbClr val="008A68"/>
-                </a:solidFill>
-                <a:latin typeface="Aptos" pitchFamily="34" charset="0"/>
-                <a:ea typeface="Aptos" pitchFamily="34" charset="-122"/>
-                <a:cs typeface="Aptos" pitchFamily="34" charset="-120"/>
-              </a:rPr>
-              <a:t>Passport, price clarity, local-language guidance</a:t>
-            </a:r>
-            <a:endParaRPr lang="en-US" sz="1080" dirty="0"/>
-          </a:p>
-        </p:txBody>
-      </p:sp>
-      <p:sp>
-        <p:nvSpPr>
-          <p:cNvPr id="13" name="Shape 11"/>
-          <p:cNvSpPr/>
-          <p:nvPr/>
-        </p:nvSpPr>
-        <p:spPr>
-          <a:xfrm>
-            <a:off x="685800" y="3392424"/>
-            <a:ext cx="10789920" cy="566928"/>
+          <p:cNvPr id="7" name="Shape 5"/>
+          <p:cNvSpPr/>
+          <p:nvPr/>
+        </p:nvSpPr>
+        <p:spPr>
+          <a:xfrm>
+            <a:off x="896112" y="2441448"/>
+            <a:ext cx="804672" cy="292608"/>
           </a:xfrm>
           <a:prstGeom prst="roundRect">
             <a:avLst>
-              <a:gd name="adj" fmla="val 25806"/>
+              <a:gd name="adj" fmla="val 50000"/>
             </a:avLst>
           </a:prstGeom>
           <a:solidFill>
-            <a:srgbClr val="EDF4F1"/>
+            <a:srgbClr val="DFF7EA"/>
           </a:solidFill>
           <a:ln w="12700">
             <a:solidFill>
-              <a:srgbClr val="EDF4F1">
+              <a:srgbClr val="DFF7EA">
                 <a:alpha val="0"/>
               </a:srgbClr>
             </a:solidFill>
@@ -8973,14 +8792,55 @@
       </p:sp>
       <p:sp>
         <p:nvSpPr>
-          <p:cNvPr id="14" name="Text 12"/>
-          <p:cNvSpPr/>
-          <p:nvPr/>
-        </p:nvSpPr>
-        <p:spPr>
-          <a:xfrm>
-            <a:off x="914400" y="3557016"/>
-            <a:ext cx="2103120" cy="164592"/>
+          <p:cNvPr id="8" name="Text 6"/>
+          <p:cNvSpPr/>
+          <p:nvPr/>
+        </p:nvSpPr>
+        <p:spPr>
+          <a:xfrm>
+            <a:off x="896112" y="2459736"/>
+            <a:ext cx="804672" cy="164592"/>
+          </a:xfrm>
+          <a:prstGeom prst="rect">
+            <a:avLst/>
+          </a:prstGeom>
+          <a:noFill/>
+          <a:ln/>
+        </p:spPr>
+        <p:txBody>
+          <a:bodyPr wrap="square" lIns="0" tIns="0" rIns="0" bIns="0" rtlCol="0" anchor="ctr">
+            <a:normAutofit/>
+          </a:bodyPr>
+          <a:lstStyle/>
+          <a:p>
+            <a:pPr algn="ctr" indent="0" marL="0">
+              <a:buNone/>
+            </a:pPr>
+            <a:r>
+              <a:rPr lang="en-US" sz="850" b="1" spc="110" kern="0" dirty="0">
+                <a:solidFill>
+                  <a:srgbClr val="008A68"/>
+                </a:solidFill>
+                <a:latin typeface="Aptos" pitchFamily="34" charset="0"/>
+                <a:ea typeface="Aptos" pitchFamily="34" charset="-122"/>
+                <a:cs typeface="Aptos" pitchFamily="34" charset="-120"/>
+              </a:rPr>
+              <a:t>LIVE</a:t>
+            </a:r>
+            <a:endParaRPr lang="en-US" sz="850" dirty="0"/>
+          </a:p>
+        </p:txBody>
+      </p:sp>
+      <p:sp>
+        <p:nvSpPr>
+          <p:cNvPr id="9" name="Text 7"/>
+          <p:cNvSpPr/>
+          <p:nvPr/>
+        </p:nvSpPr>
+        <p:spPr>
+          <a:xfrm>
+            <a:off x="1920240" y="2423160"/>
+            <a:ext cx="3383280" cy="228600"/>
           </a:xfrm>
           <a:prstGeom prst="rect">
             <a:avLst/>
@@ -8998,7 +8858,7 @@
               <a:buNone/>
             </a:pPr>
             <a:r>
-              <a:rPr lang="en-US" sz="1150" b="1" dirty="0">
+              <a:rPr lang="en-US" sz="1500" b="1" dirty="0">
                 <a:solidFill>
                   <a:srgbClr val="063A45"/>
                 </a:solidFill>
@@ -9006,31 +8866,31 @@
                 <a:ea typeface="Aptos" pitchFamily="34" charset="-122"/>
                 <a:cs typeface="Aptos" pitchFamily="34" charset="-120"/>
               </a:rPr>
-              <a:t>After sending</a:t>
-            </a:r>
-            <a:endParaRPr lang="en-US" sz="1150" dirty="0"/>
-          </a:p>
-        </p:txBody>
-      </p:sp>
-      <p:sp>
-        <p:nvSpPr>
-          <p:cNvPr id="15" name="Text 13"/>
-          <p:cNvSpPr/>
-          <p:nvPr/>
-        </p:nvSpPr>
-        <p:spPr>
-          <a:xfrm>
-            <a:off x="3749040" y="3557016"/>
-            <a:ext cx="3017520" cy="164592"/>
-          </a:xfrm>
-          <a:prstGeom prst="rect">
-            <a:avLst/>
-          </a:prstGeom>
-          <a:noFill/>
-          <a:ln/>
-        </p:spPr>
-        <p:txBody>
-          <a:bodyPr wrap="square" lIns="0" tIns="0" rIns="0" bIns="0" rtlCol="0" anchor="ctr">
+              <a:t>Mobile-first deployed experience</a:t>
+            </a:r>
+            <a:endParaRPr lang="en-US" sz="1500" dirty="0"/>
+          </a:p>
+        </p:txBody>
+      </p:sp>
+      <p:sp>
+        <p:nvSpPr>
+          <p:cNvPr id="10" name="Text 8"/>
+          <p:cNvSpPr/>
+          <p:nvPr/>
+        </p:nvSpPr>
+        <p:spPr>
+          <a:xfrm>
+            <a:off x="1920240" y="2761488"/>
+            <a:ext cx="3566160" cy="347472"/>
+          </a:xfrm>
+          <a:prstGeom prst="rect">
+            <a:avLst/>
+          </a:prstGeom>
+          <a:noFill/>
+          <a:ln/>
+        </p:spPr>
+        <p:txBody>
+          <a:bodyPr wrap="square" lIns="0" tIns="0" rIns="0" bIns="0" rtlCol="0" anchor="t">
             <a:normAutofit/>
           </a:bodyPr>
           <a:lstStyle/>
@@ -9039,7 +8899,7 @@
               <a:buNone/>
             </a:pPr>
             <a:r>
-              <a:rPr lang="en-US" sz="1080" dirty="0">
+              <a:rPr lang="en-US" sz="1130" dirty="0">
                 <a:solidFill>
                   <a:srgbClr val="60767A"/>
                 </a:solidFill>
@@ -9047,67 +8907,26 @@
                 <a:ea typeface="Aptos" pitchFamily="34" charset="-122"/>
                 <a:cs typeface="Aptos" pitchFamily="34" charset="-120"/>
               </a:rPr>
-              <a:t>Status disappears</a:t>
-            </a:r>
-            <a:endParaRPr lang="en-US" sz="1080" dirty="0"/>
-          </a:p>
-        </p:txBody>
-      </p:sp>
-      <p:sp>
-        <p:nvSpPr>
-          <p:cNvPr id="16" name="Text 14"/>
-          <p:cNvSpPr/>
-          <p:nvPr/>
-        </p:nvSpPr>
-        <p:spPr>
-          <a:xfrm>
-            <a:off x="7498080" y="3538728"/>
-            <a:ext cx="3383280" cy="201168"/>
-          </a:xfrm>
-          <a:prstGeom prst="rect">
-            <a:avLst/>
-          </a:prstGeom>
-          <a:noFill/>
-          <a:ln/>
-        </p:spPr>
-        <p:txBody>
-          <a:bodyPr wrap="square" lIns="0" tIns="0" rIns="0" bIns="0" rtlCol="0" anchor="ctr">
-            <a:normAutofit/>
-          </a:bodyPr>
-          <a:lstStyle/>
-          <a:p>
-            <a:pPr algn="l" indent="0" marL="0">
-              <a:buNone/>
-            </a:pPr>
-            <a:r>
-              <a:rPr lang="en-US" sz="1080" b="1" dirty="0">
-                <a:solidFill>
-                  <a:srgbClr val="008A68"/>
-                </a:solidFill>
-                <a:latin typeface="Aptos" pitchFamily="34" charset="0"/>
-                <a:ea typeface="Aptos" pitchFamily="34" charset="-122"/>
-                <a:cs typeface="Aptos" pitchFamily="34" charset="-120"/>
-              </a:rPr>
-              <a:t>Receipt, Stellar proof, history and SMS sandbox updates</a:t>
-            </a:r>
-            <a:endParaRPr lang="en-US" sz="1080" dirty="0"/>
-          </a:p>
-        </p:txBody>
-      </p:sp>
-      <p:sp>
-        <p:nvSpPr>
-          <p:cNvPr id="17" name="Shape 15"/>
-          <p:cNvSpPr/>
-          <p:nvPr/>
-        </p:nvSpPr>
-        <p:spPr>
-          <a:xfrm>
-            <a:off x="685800" y="4041648"/>
-            <a:ext cx="10789920" cy="566928"/>
+              <a:t>Judges can open HomeWard on a phone, register, and complete the core journey.</a:t>
+            </a:r>
+            <a:endParaRPr lang="en-US" sz="1130" dirty="0"/>
+          </a:p>
+        </p:txBody>
+      </p:sp>
+      <p:sp>
+        <p:nvSpPr>
+          <p:cNvPr id="11" name="Shape 9"/>
+          <p:cNvSpPr/>
+          <p:nvPr/>
+        </p:nvSpPr>
+        <p:spPr>
+          <a:xfrm>
+            <a:off x="6190488" y="2240280"/>
+            <a:ext cx="5102352" cy="1097280"/>
           </a:xfrm>
           <a:prstGeom prst="roundRect">
             <a:avLst>
-              <a:gd name="adj" fmla="val 25806"/>
+              <a:gd name="adj" fmla="val 13333"/>
             </a:avLst>
           </a:prstGeom>
           <a:solidFill>
@@ -9125,149 +8944,26 @@
       </p:sp>
       <p:sp>
         <p:nvSpPr>
-          <p:cNvPr id="18" name="Text 16"/>
-          <p:cNvSpPr/>
-          <p:nvPr/>
-        </p:nvSpPr>
-        <p:spPr>
-          <a:xfrm>
-            <a:off x="914400" y="4206240"/>
-            <a:ext cx="2103120" cy="164592"/>
-          </a:xfrm>
-          <a:prstGeom prst="rect">
-            <a:avLst/>
-          </a:prstGeom>
-          <a:noFill/>
-          <a:ln/>
-        </p:spPr>
-        <p:txBody>
-          <a:bodyPr wrap="square" lIns="0" tIns="0" rIns="0" bIns="0" rtlCol="0" anchor="ctr">
-            <a:normAutofit/>
-          </a:bodyPr>
-          <a:lstStyle/>
-          <a:p>
-            <a:pPr algn="l" indent="0" marL="0">
-              <a:buNone/>
-            </a:pPr>
-            <a:r>
-              <a:rPr lang="en-US" sz="1150" b="1" dirty="0">
-                <a:solidFill>
-                  <a:srgbClr val="063A45"/>
-                </a:solidFill>
-                <a:latin typeface="Aptos" pitchFamily="34" charset="0"/>
-                <a:ea typeface="Aptos" pitchFamily="34" charset="-122"/>
-                <a:cs typeface="Aptos" pitchFamily="34" charset="-120"/>
-              </a:rPr>
-              <a:t>Every month</a:t>
-            </a:r>
-            <a:endParaRPr lang="en-US" sz="1150" dirty="0"/>
-          </a:p>
-        </p:txBody>
-      </p:sp>
-      <p:sp>
-        <p:nvSpPr>
-          <p:cNvPr id="19" name="Text 17"/>
-          <p:cNvSpPr/>
-          <p:nvPr/>
-        </p:nvSpPr>
-        <p:spPr>
-          <a:xfrm>
-            <a:off x="3749040" y="4206240"/>
-            <a:ext cx="3017520" cy="164592"/>
-          </a:xfrm>
-          <a:prstGeom prst="rect">
-            <a:avLst/>
-          </a:prstGeom>
-          <a:noFill/>
-          <a:ln/>
-        </p:spPr>
-        <p:txBody>
-          <a:bodyPr wrap="square" lIns="0" tIns="0" rIns="0" bIns="0" rtlCol="0" anchor="ctr">
-            <a:normAutofit/>
-          </a:bodyPr>
-          <a:lstStyle/>
-          <a:p>
-            <a:pPr algn="l" indent="0" marL="0">
-              <a:buNone/>
-            </a:pPr>
-            <a:r>
-              <a:rPr lang="en-US" sz="1080" dirty="0">
-                <a:solidFill>
-                  <a:srgbClr val="60767A"/>
-                </a:solidFill>
-                <a:latin typeface="Aptos" pitchFamily="34" charset="0"/>
-                <a:ea typeface="Aptos" pitchFamily="34" charset="-122"/>
-                <a:cs typeface="Aptos" pitchFamily="34" charset="-120"/>
-              </a:rPr>
-              <a:t>Repeat transfers feel fragmented</a:t>
-            </a:r>
-            <a:endParaRPr lang="en-US" sz="1080" dirty="0"/>
-          </a:p>
-        </p:txBody>
-      </p:sp>
-      <p:sp>
-        <p:nvSpPr>
-          <p:cNvPr id="20" name="Text 18"/>
-          <p:cNvSpPr/>
-          <p:nvPr/>
-        </p:nvSpPr>
-        <p:spPr>
-          <a:xfrm>
-            <a:off x="7498080" y="4187952"/>
-            <a:ext cx="3383280" cy="201168"/>
-          </a:xfrm>
-          <a:prstGeom prst="rect">
-            <a:avLst/>
-          </a:prstGeom>
-          <a:noFill/>
-          <a:ln/>
-        </p:spPr>
-        <p:txBody>
-          <a:bodyPr wrap="square" lIns="0" tIns="0" rIns="0" bIns="0" rtlCol="0" anchor="ctr">
-            <a:normAutofit/>
-          </a:bodyPr>
-          <a:lstStyle/>
-          <a:p>
-            <a:pPr algn="l" indent="0" marL="0">
-              <a:buNone/>
-            </a:pPr>
-            <a:r>
-              <a:rPr lang="en-US" sz="1080" b="1" dirty="0">
-                <a:solidFill>
-                  <a:srgbClr val="008A68"/>
-                </a:solidFill>
-                <a:latin typeface="Aptos" pitchFamily="34" charset="0"/>
-                <a:ea typeface="Aptos" pitchFamily="34" charset="-122"/>
-                <a:cs typeface="Aptos" pitchFamily="34" charset="-120"/>
-              </a:rPr>
-              <a:t>Circles, Goals, plans and family progress</a:t>
-            </a:r>
-            <a:endParaRPr lang="en-US" sz="1080" dirty="0"/>
-          </a:p>
-        </p:txBody>
-      </p:sp>
-      <p:sp>
-        <p:nvSpPr>
-          <p:cNvPr id="21" name="Shape 19"/>
-          <p:cNvSpPr/>
-          <p:nvPr/>
-        </p:nvSpPr>
-        <p:spPr>
-          <a:xfrm>
-            <a:off x="685800" y="4690872"/>
-            <a:ext cx="10789920" cy="566928"/>
+          <p:cNvPr id="12" name="Shape 10"/>
+          <p:cNvSpPr/>
+          <p:nvPr/>
+        </p:nvSpPr>
+        <p:spPr>
+          <a:xfrm>
+            <a:off x="6400800" y="2441448"/>
+            <a:ext cx="804672" cy="292608"/>
           </a:xfrm>
           <a:prstGeom prst="roundRect">
             <a:avLst>
-              <a:gd name="adj" fmla="val 25806"/>
+              <a:gd name="adj" fmla="val 50000"/>
             </a:avLst>
           </a:prstGeom>
           <a:solidFill>
-            <a:srgbClr val="EDF4F1"/>
+            <a:srgbClr val="0D5A57"/>
           </a:solidFill>
           <a:ln w="12700">
             <a:solidFill>
-              <a:srgbClr val="EDF4F1">
+              <a:srgbClr val="0D5A57">
                 <a:alpha val="0"/>
               </a:srgbClr>
             </a:solidFill>
@@ -9277,14 +8973,55 @@
       </p:sp>
       <p:sp>
         <p:nvSpPr>
-          <p:cNvPr id="22" name="Text 20"/>
-          <p:cNvSpPr/>
-          <p:nvPr/>
-        </p:nvSpPr>
-        <p:spPr>
-          <a:xfrm>
-            <a:off x="914400" y="4855464"/>
-            <a:ext cx="2103120" cy="164592"/>
+          <p:cNvPr id="13" name="Text 11"/>
+          <p:cNvSpPr/>
+          <p:nvPr/>
+        </p:nvSpPr>
+        <p:spPr>
+          <a:xfrm>
+            <a:off x="6400800" y="2459736"/>
+            <a:ext cx="804672" cy="164592"/>
+          </a:xfrm>
+          <a:prstGeom prst="rect">
+            <a:avLst/>
+          </a:prstGeom>
+          <a:noFill/>
+          <a:ln/>
+        </p:spPr>
+        <p:txBody>
+          <a:bodyPr wrap="square" lIns="0" tIns="0" rIns="0" bIns="0" rtlCol="0" anchor="ctr">
+            <a:normAutofit/>
+          </a:bodyPr>
+          <a:lstStyle/>
+          <a:p>
+            <a:pPr algn="ctr" indent="0" marL="0">
+              <a:buNone/>
+            </a:pPr>
+            <a:r>
+              <a:rPr lang="en-US" sz="850" b="1" spc="110" kern="0" dirty="0">
+                <a:solidFill>
+                  <a:srgbClr val="C9F04A"/>
+                </a:solidFill>
+                <a:latin typeface="Aptos" pitchFamily="34" charset="0"/>
+                <a:ea typeface="Aptos" pitchFamily="34" charset="-122"/>
+                <a:cs typeface="Aptos" pitchFamily="34" charset="-120"/>
+              </a:rPr>
+              <a:t>REAL</a:t>
+            </a:r>
+            <a:endParaRPr lang="en-US" sz="850" dirty="0"/>
+          </a:p>
+        </p:txBody>
+      </p:sp>
+      <p:sp>
+        <p:nvSpPr>
+          <p:cNvPr id="14" name="Text 12"/>
+          <p:cNvSpPr/>
+          <p:nvPr/>
+        </p:nvSpPr>
+        <p:spPr>
+          <a:xfrm>
+            <a:off x="7424928" y="2423160"/>
+            <a:ext cx="3383280" cy="228600"/>
           </a:xfrm>
           <a:prstGeom prst="rect">
             <a:avLst/>
@@ -9302,7 +9039,7 @@
               <a:buNone/>
             </a:pPr>
             <a:r>
-              <a:rPr lang="en-US" sz="1150" b="1" dirty="0">
+              <a:rPr lang="en-US" sz="1500" b="1" dirty="0">
                 <a:solidFill>
                   <a:srgbClr val="063A45"/>
                 </a:solidFill>
@@ -9310,11 +9047,291 @@
                 <a:ea typeface="Aptos" pitchFamily="34" charset="-122"/>
                 <a:cs typeface="Aptos" pitchFamily="34" charset="-120"/>
               </a:rPr>
-              <a:t>For low-literacy users</a:t>
-            </a:r>
-            <a:endParaRPr lang="en-US" sz="1150" dirty="0"/>
-          </a:p>
-        </p:txBody>
+              <a:t>Stellar Testnet settlement</a:t>
+            </a:r>
+            <a:endParaRPr lang="en-US" sz="1500" dirty="0"/>
+          </a:p>
+        </p:txBody>
+      </p:sp>
+      <p:sp>
+        <p:nvSpPr>
+          <p:cNvPr id="15" name="Text 13"/>
+          <p:cNvSpPr/>
+          <p:nvPr/>
+        </p:nvSpPr>
+        <p:spPr>
+          <a:xfrm>
+            <a:off x="7424928" y="2761488"/>
+            <a:ext cx="3566160" cy="347472"/>
+          </a:xfrm>
+          <a:prstGeom prst="rect">
+            <a:avLst/>
+          </a:prstGeom>
+          <a:noFill/>
+          <a:ln/>
+        </p:spPr>
+        <p:txBody>
+          <a:bodyPr wrap="square" lIns="0" tIns="0" rIns="0" bIns="0" rtlCol="0" anchor="t">
+            <a:normAutofit/>
+          </a:bodyPr>
+          <a:lstStyle/>
+          <a:p>
+            <a:pPr algn="l" indent="0" marL="0">
+              <a:buNone/>
+            </a:pPr>
+            <a:r>
+              <a:rPr lang="en-US" sz="1130" dirty="0">
+                <a:solidFill>
+                  <a:srgbClr val="60767A"/>
+                </a:solidFill>
+                <a:latin typeface="Aptos" pitchFamily="34" charset="0"/>
+                <a:ea typeface="Aptos" pitchFamily="34" charset="-122"/>
+                <a:cs typeface="Aptos" pitchFamily="34" charset="-120"/>
+              </a:rPr>
+              <a:t>Individual wallets, Test USDC transfers, hashes and explorer links are in the demo.</a:t>
+            </a:r>
+            <a:endParaRPr lang="en-US" sz="1130" dirty="0"/>
+          </a:p>
+        </p:txBody>
+      </p:sp>
+      <p:sp>
+        <p:nvSpPr>
+          <p:cNvPr id="16" name="Shape 14"/>
+          <p:cNvSpPr/>
+          <p:nvPr/>
+        </p:nvSpPr>
+        <p:spPr>
+          <a:xfrm>
+            <a:off x="685800" y="3657600"/>
+            <a:ext cx="5102352" cy="1097280"/>
+          </a:xfrm>
+          <a:prstGeom prst="roundRect">
+            <a:avLst>
+              <a:gd name="adj" fmla="val 13333"/>
+            </a:avLst>
+          </a:prstGeom>
+          <a:solidFill>
+            <a:srgbClr val="FFFFFF"/>
+          </a:solidFill>
+          <a:ln w="12700">
+            <a:solidFill>
+              <a:srgbClr val="FFFFFF">
+                <a:alpha val="0"/>
+              </a:srgbClr>
+            </a:solidFill>
+            <a:prstDash val="solid"/>
+          </a:ln>
+        </p:spPr>
+      </p:sp>
+      <p:sp>
+        <p:nvSpPr>
+          <p:cNvPr id="17" name="Shape 15"/>
+          <p:cNvSpPr/>
+          <p:nvPr/>
+        </p:nvSpPr>
+        <p:spPr>
+          <a:xfrm>
+            <a:off x="896112" y="3858768"/>
+            <a:ext cx="804672" cy="292608"/>
+          </a:xfrm>
+          <a:prstGeom prst="roundRect">
+            <a:avLst>
+              <a:gd name="adj" fmla="val 50000"/>
+            </a:avLst>
+          </a:prstGeom>
+          <a:solidFill>
+            <a:srgbClr val="DFF7EA"/>
+          </a:solidFill>
+          <a:ln w="12700">
+            <a:solidFill>
+              <a:srgbClr val="DFF7EA">
+                <a:alpha val="0"/>
+              </a:srgbClr>
+            </a:solidFill>
+            <a:prstDash val="solid"/>
+          </a:ln>
+        </p:spPr>
+      </p:sp>
+      <p:sp>
+        <p:nvSpPr>
+          <p:cNvPr id="18" name="Text 16"/>
+          <p:cNvSpPr/>
+          <p:nvPr/>
+        </p:nvSpPr>
+        <p:spPr>
+          <a:xfrm>
+            <a:off x="896112" y="3877056"/>
+            <a:ext cx="804672" cy="164592"/>
+          </a:xfrm>
+          <a:prstGeom prst="rect">
+            <a:avLst/>
+          </a:prstGeom>
+          <a:noFill/>
+          <a:ln/>
+        </p:spPr>
+        <p:txBody>
+          <a:bodyPr wrap="square" lIns="0" tIns="0" rIns="0" bIns="0" rtlCol="0" anchor="ctr">
+            <a:normAutofit/>
+          </a:bodyPr>
+          <a:lstStyle/>
+          <a:p>
+            <a:pPr algn="ctr" indent="0" marL="0">
+              <a:buNone/>
+            </a:pPr>
+            <a:r>
+              <a:rPr lang="en-US" sz="850" b="1" spc="110" kern="0" dirty="0">
+                <a:solidFill>
+                  <a:srgbClr val="008A68"/>
+                </a:solidFill>
+                <a:latin typeface="Aptos" pitchFamily="34" charset="0"/>
+                <a:ea typeface="Aptos" pitchFamily="34" charset="-122"/>
+                <a:cs typeface="Aptos" pitchFamily="34" charset="-120"/>
+              </a:rPr>
+              <a:t>BUILT</a:t>
+            </a:r>
+            <a:endParaRPr lang="en-US" sz="850" dirty="0"/>
+          </a:p>
+        </p:txBody>
+      </p:sp>
+      <p:sp>
+        <p:nvSpPr>
+          <p:cNvPr id="19" name="Text 17"/>
+          <p:cNvSpPr/>
+          <p:nvPr/>
+        </p:nvSpPr>
+        <p:spPr>
+          <a:xfrm>
+            <a:off x="1920240" y="3840480"/>
+            <a:ext cx="3383280" cy="228600"/>
+          </a:xfrm>
+          <a:prstGeom prst="rect">
+            <a:avLst/>
+          </a:prstGeom>
+          <a:noFill/>
+          <a:ln/>
+        </p:spPr>
+        <p:txBody>
+          <a:bodyPr wrap="square" lIns="0" tIns="0" rIns="0" bIns="0" rtlCol="0" anchor="ctr">
+            <a:normAutofit/>
+          </a:bodyPr>
+          <a:lstStyle/>
+          <a:p>
+            <a:pPr algn="l" indent="0" marL="0">
+              <a:buNone/>
+            </a:pPr>
+            <a:r>
+              <a:rPr lang="en-US" sz="1500" b="1" dirty="0">
+                <a:solidFill>
+                  <a:srgbClr val="063A45"/>
+                </a:solidFill>
+                <a:latin typeface="Aptos" pitchFamily="34" charset="0"/>
+                <a:ea typeface="Aptos" pitchFamily="34" charset="-122"/>
+                <a:cs typeface="Aptos" pitchFamily="34" charset="-120"/>
+              </a:rPr>
+              <a:t>Family-support operating system</a:t>
+            </a:r>
+            <a:endParaRPr lang="en-US" sz="1500" dirty="0"/>
+          </a:p>
+        </p:txBody>
+      </p:sp>
+      <p:sp>
+        <p:nvSpPr>
+          <p:cNvPr id="20" name="Text 18"/>
+          <p:cNvSpPr/>
+          <p:nvPr/>
+        </p:nvSpPr>
+        <p:spPr>
+          <a:xfrm>
+            <a:off x="1920240" y="4178808"/>
+            <a:ext cx="3566160" cy="347472"/>
+          </a:xfrm>
+          <a:prstGeom prst="rect">
+            <a:avLst/>
+          </a:prstGeom>
+          <a:noFill/>
+          <a:ln/>
+        </p:spPr>
+        <p:txBody>
+          <a:bodyPr wrap="square" lIns="0" tIns="0" rIns="0" bIns="0" rtlCol="0" anchor="t">
+            <a:normAutofit/>
+          </a:bodyPr>
+          <a:lstStyle/>
+          <a:p>
+            <a:pPr algn="l" indent="0" marL="0">
+              <a:buNone/>
+            </a:pPr>
+            <a:r>
+              <a:rPr lang="en-US" sz="1130" dirty="0">
+                <a:solidFill>
+                  <a:srgbClr val="60767A"/>
+                </a:solidFill>
+                <a:latin typeface="Aptos" pitchFamily="34" charset="0"/>
+                <a:ea typeface="Aptos" pitchFamily="34" charset="-122"/>
+                <a:cs typeface="Aptos" pitchFamily="34" charset="-120"/>
+              </a:rPr>
+              <a:t>Recipient Passports, Goals, Circles, receipts, filters, notifications and transfer guardrails.</a:t>
+            </a:r>
+            <a:endParaRPr lang="en-US" sz="1130" dirty="0"/>
+          </a:p>
+        </p:txBody>
+      </p:sp>
+      <p:sp>
+        <p:nvSpPr>
+          <p:cNvPr id="21" name="Shape 19"/>
+          <p:cNvSpPr/>
+          <p:nvPr/>
+        </p:nvSpPr>
+        <p:spPr>
+          <a:xfrm>
+            <a:off x="6190488" y="3657600"/>
+            <a:ext cx="5102352" cy="1097280"/>
+          </a:xfrm>
+          <a:prstGeom prst="roundRect">
+            <a:avLst>
+              <a:gd name="adj" fmla="val 13333"/>
+            </a:avLst>
+          </a:prstGeom>
+          <a:solidFill>
+            <a:srgbClr val="FFFFFF"/>
+          </a:solidFill>
+          <a:ln w="12700">
+            <a:solidFill>
+              <a:srgbClr val="FFFFFF">
+                <a:alpha val="0"/>
+              </a:srgbClr>
+            </a:solidFill>
+            <a:prstDash val="solid"/>
+          </a:ln>
+        </p:spPr>
+      </p:sp>
+      <p:sp>
+        <p:nvSpPr>
+          <p:cNvPr id="22" name="Shape 20"/>
+          <p:cNvSpPr/>
+          <p:nvPr/>
+        </p:nvSpPr>
+        <p:spPr>
+          <a:xfrm>
+            <a:off x="6400800" y="3858768"/>
+            <a:ext cx="804672" cy="292608"/>
+          </a:xfrm>
+          <a:prstGeom prst="roundRect">
+            <a:avLst>
+              <a:gd name="adj" fmla="val 50000"/>
+            </a:avLst>
+          </a:prstGeom>
+          <a:solidFill>
+            <a:srgbClr val="DFF7EA"/>
+          </a:solidFill>
+          <a:ln w="12700">
+            <a:solidFill>
+              <a:srgbClr val="DFF7EA">
+                <a:alpha val="0"/>
+              </a:srgbClr>
+            </a:solidFill>
+            <a:prstDash val="solid"/>
+          </a:ln>
+        </p:spPr>
       </p:sp>
       <p:sp>
         <p:nvSpPr>
@@ -9324,8 +9341,49 @@
         </p:nvSpPr>
         <p:spPr>
           <a:xfrm>
-            <a:off x="3749040" y="4855464"/>
-            <a:ext cx="3017520" cy="164592"/>
+            <a:off x="6400800" y="3877056"/>
+            <a:ext cx="804672" cy="164592"/>
+          </a:xfrm>
+          <a:prstGeom prst="rect">
+            <a:avLst/>
+          </a:prstGeom>
+          <a:noFill/>
+          <a:ln/>
+        </p:spPr>
+        <p:txBody>
+          <a:bodyPr wrap="square" lIns="0" tIns="0" rIns="0" bIns="0" rtlCol="0" anchor="ctr">
+            <a:normAutofit/>
+          </a:bodyPr>
+          <a:lstStyle/>
+          <a:p>
+            <a:pPr algn="ctr" indent="0" marL="0">
+              <a:buNone/>
+            </a:pPr>
+            <a:r>
+              <a:rPr lang="en-US" sz="850" b="1" spc="110" kern="0" dirty="0">
+                <a:solidFill>
+                  <a:srgbClr val="008A68"/>
+                </a:solidFill>
+                <a:latin typeface="Aptos" pitchFamily="34" charset="0"/>
+                <a:ea typeface="Aptos" pitchFamily="34" charset="-122"/>
+                <a:cs typeface="Aptos" pitchFamily="34" charset="-120"/>
+              </a:rPr>
+              <a:t>ACCESSIBLE</a:t>
+            </a:r>
+            <a:endParaRPr lang="en-US" sz="850" dirty="0"/>
+          </a:p>
+        </p:txBody>
+      </p:sp>
+      <p:sp>
+        <p:nvSpPr>
+          <p:cNvPr id="24" name="Text 22"/>
+          <p:cNvSpPr/>
+          <p:nvPr/>
+        </p:nvSpPr>
+        <p:spPr>
+          <a:xfrm>
+            <a:off x="7424928" y="3840480"/>
+            <a:ext cx="3383280" cy="228600"/>
           </a:xfrm>
           <a:prstGeom prst="rect">
             <a:avLst/>
@@ -9343,7 +9401,48 @@
               <a:buNone/>
             </a:pPr>
             <a:r>
-              <a:rPr lang="en-US" sz="1080" dirty="0">
+              <a:rPr lang="en-US" sz="1500" b="1" dirty="0">
+                <a:solidFill>
+                  <a:srgbClr val="063A45"/>
+                </a:solidFill>
+                <a:latin typeface="Aptos" pitchFamily="34" charset="0"/>
+                <a:ea typeface="Aptos" pitchFamily="34" charset="-122"/>
+                <a:cs typeface="Aptos" pitchFamily="34" charset="-120"/>
+              </a:rPr>
+              <a:t>Sunbird AI language layer</a:t>
+            </a:r>
+            <a:endParaRPr lang="en-US" sz="1500" dirty="0"/>
+          </a:p>
+        </p:txBody>
+      </p:sp>
+      <p:sp>
+        <p:nvSpPr>
+          <p:cNvPr id="25" name="Text 23"/>
+          <p:cNvSpPr/>
+          <p:nvPr/>
+        </p:nvSpPr>
+        <p:spPr>
+          <a:xfrm>
+            <a:off x="7424928" y="4178808"/>
+            <a:ext cx="3566160" cy="347472"/>
+          </a:xfrm>
+          <a:prstGeom prst="rect">
+            <a:avLst/>
+          </a:prstGeom>
+          <a:noFill/>
+          <a:ln/>
+        </p:spPr>
+        <p:txBody>
+          <a:bodyPr wrap="square" lIns="0" tIns="0" rIns="0" bIns="0" rtlCol="0" anchor="t">
+            <a:normAutofit/>
+          </a:bodyPr>
+          <a:lstStyle/>
+          <a:p>
+            <a:pPr algn="l" indent="0" marL="0">
+              <a:buNone/>
+            </a:pPr>
+            <a:r>
+              <a:rPr lang="en-US" sz="1130" dirty="0">
                 <a:solidFill>
                   <a:srgbClr val="60767A"/>
                 </a:solidFill>
@@ -9351,56 +9450,85 @@
                 <a:ea typeface="Aptos" pitchFamily="34" charset="-122"/>
                 <a:cs typeface="Aptos" pitchFamily="34" charset="-120"/>
               </a:rPr>
-              <a:t>Financial English excludes</a:t>
-            </a:r>
-            <a:endParaRPr lang="en-US" sz="1080" dirty="0"/>
-          </a:p>
-        </p:txBody>
-      </p:sp>
-      <p:sp>
-        <p:nvSpPr>
-          <p:cNvPr id="24" name="Text 22"/>
-          <p:cNvSpPr/>
-          <p:nvPr/>
-        </p:nvSpPr>
-        <p:spPr>
-          <a:xfrm>
-            <a:off x="7498080" y="4837176"/>
-            <a:ext cx="3383280" cy="201168"/>
-          </a:xfrm>
-          <a:prstGeom prst="rect">
-            <a:avLst/>
-          </a:prstGeom>
-          <a:noFill/>
-          <a:ln/>
-        </p:spPr>
-        <p:txBody>
-          <a:bodyPr wrap="square" lIns="0" tIns="0" rIns="0" bIns="0" rtlCol="0" anchor="ctr">
-            <a:normAutofit/>
-          </a:bodyPr>
-          <a:lstStyle/>
-          <a:p>
-            <a:pPr algn="l" indent="0" marL="0">
-              <a:buNone/>
-            </a:pPr>
-            <a:r>
-              <a:rPr lang="en-US" sz="1080" b="1" dirty="0">
-                <a:solidFill>
-                  <a:srgbClr val="008A68"/>
-                </a:solidFill>
-                <a:latin typeface="Aptos" pitchFamily="34" charset="0"/>
-                <a:ea typeface="Aptos" pitchFamily="34" charset="-122"/>
-                <a:cs typeface="Aptos" pitchFamily="34" charset="-120"/>
-              </a:rPr>
-              <a:t>Sunbird-powered local language and voice access</a:t>
-            </a:r>
-            <a:endParaRPr lang="en-US" sz="1080" dirty="0"/>
-          </a:p>
-        </p:txBody>
-      </p:sp>
-      <p:sp>
-        <p:nvSpPr>
-          <p:cNvPr id="25" name="Text 23"/>
+              <a:t>Luganda interface coverage plus speech and conversational support when configured.</a:t>
+            </a:r>
+            <a:endParaRPr lang="en-US" sz="1130" dirty="0"/>
+          </a:p>
+        </p:txBody>
+      </p:sp>
+      <p:sp>
+        <p:nvSpPr>
+          <p:cNvPr id="26" name="Shape 24"/>
+          <p:cNvSpPr/>
+          <p:nvPr/>
+        </p:nvSpPr>
+        <p:spPr>
+          <a:xfrm>
+            <a:off x="685800" y="5257800"/>
+            <a:ext cx="10789920" cy="530352"/>
+          </a:xfrm>
+          <a:prstGeom prst="roundRect">
+            <a:avLst>
+              <a:gd name="adj" fmla="val 27586"/>
+            </a:avLst>
+          </a:prstGeom>
+          <a:solidFill>
+            <a:srgbClr val="DFF7EA"/>
+          </a:solidFill>
+          <a:ln w="12700">
+            <a:solidFill>
+              <a:srgbClr val="DFF7EA">
+                <a:alpha val="0"/>
+              </a:srgbClr>
+            </a:solidFill>
+            <a:prstDash val="solid"/>
+          </a:ln>
+        </p:spPr>
+      </p:sp>
+      <p:sp>
+        <p:nvSpPr>
+          <p:cNvPr id="27" name="Text 25"/>
+          <p:cNvSpPr/>
+          <p:nvPr/>
+        </p:nvSpPr>
+        <p:spPr>
+          <a:xfrm>
+            <a:off x="914400" y="5422392"/>
+            <a:ext cx="10332720" cy="164592"/>
+          </a:xfrm>
+          <a:prstGeom prst="rect">
+            <a:avLst/>
+          </a:prstGeom>
+          <a:noFill/>
+          <a:ln/>
+        </p:spPr>
+        <p:txBody>
+          <a:bodyPr wrap="square" lIns="0" tIns="0" rIns="0" bIns="0" rtlCol="0" anchor="ctr">
+            <a:normAutofit/>
+          </a:bodyPr>
+          <a:lstStyle/>
+          <a:p>
+            <a:pPr algn="ctr" indent="0" marL="0">
+              <a:buNone/>
+            </a:pPr>
+            <a:r>
+              <a:rPr lang="en-US" sz="1350" b="1" dirty="0">
+                <a:solidFill>
+                  <a:srgbClr val="063A45"/>
+                </a:solidFill>
+                <a:latin typeface="Aptos" pitchFamily="34" charset="0"/>
+                <a:ea typeface="Aptos" pitchFamily="34" charset="-122"/>
+                <a:cs typeface="Aptos" pitchFamily="34" charset="-120"/>
+              </a:rPr>
+              <a:t>Next traction milestone: a regulated UAE-to-Uganda pilot with repeat family-support behavior measured in the field.</a:t>
+            </a:r>
+            <a:endParaRPr lang="en-US" sz="1350" dirty="0"/>
+          </a:p>
+        </p:txBody>
+      </p:sp>
+      <p:sp>
+        <p:nvSpPr>
+          <p:cNvPr id="28" name="Text 26"/>
           <p:cNvSpPr/>
           <p:nvPr/>
         </p:nvSpPr>
@@ -9441,7 +9569,7 @@
       </p:sp>
       <p:sp>
         <p:nvSpPr>
-          <p:cNvPr id="26" name="Text 24"/>
+          <p:cNvPr id="29" name="Text 27"/>
           <p:cNvSpPr/>
           <p:nvPr/>
         </p:nvSpPr>

</xml_diff>

<commit_message>
Clarify judge docs and pitch
</commit_message>
<xml_diff>
--- a/HomeWard_DevFest_Winning_Pitch_Deck.pptx
+++ b/HomeWard_DevFest_Winning_Pitch_Deck.pptx
@@ -1892,7 +1892,7 @@
                 <a:ea typeface="Aptos" pitchFamily="34" charset="-122"/>
                 <a:cs typeface="Aptos" pitchFamily="34" charset="-120"/>
               </a:rPr>
-              <a:t>Sunday sends money home</a:t>
+              <a:t>A worker abroad sends money</a:t>
             </a:r>
             <a:endParaRPr lang="en-US" sz="3300" dirty="0"/>
           </a:p>
@@ -1909,7 +1909,7 @@
                 <a:ea typeface="Aptos" pitchFamily="34" charset="-122"/>
                 <a:cs typeface="Aptos" pitchFamily="34" charset="-120"/>
               </a:rPr>
-              <a:t>every month.</a:t>
+              <a:t>home every month.</a:t>
             </a:r>
             <a:endParaRPr lang="en-US" sz="3300" dirty="0"/>
           </a:p>
@@ -1924,7 +1924,7 @@
         <p:spPr>
           <a:xfrm>
             <a:off x="713232" y="2487168"/>
-            <a:ext cx="5577840" cy="274320"/>
+            <a:ext cx="5760720" cy="274320"/>
           </a:xfrm>
           <a:prstGeom prst="rect">
             <a:avLst/>
@@ -1950,7 +1950,7 @@
                 <a:ea typeface="Aptos" pitchFamily="34" charset="-122"/>
                 <a:cs typeface="Aptos" pitchFamily="34" charset="-120"/>
               </a:rPr>
-              <a:t>But after pressing send, she still asks:</a:t>
+              <a:t>But after pressing send, one question remains:</a:t>
             </a:r>
             <a:endParaRPr lang="en-US" sz="1600" dirty="0"/>
           </a:p>
@@ -1991,7 +1991,7 @@
                 <a:ea typeface="Aptos" pitchFamily="34" charset="-122"/>
                 <a:cs typeface="Aptos" pitchFamily="34" charset="-120"/>
               </a:rPr>
-              <a:t>"Did it reach the right person?</a:t>
+              <a:t>"Did it reach the right</a:t>
             </a:r>
             <a:endParaRPr lang="en-US" sz="2300" dirty="0"/>
           </a:p>
@@ -2008,7 +2008,7 @@
                 <a:ea typeface="Aptos" pitchFamily="34" charset="-122"/>
                 <a:cs typeface="Aptos" pitchFamily="34" charset="-120"/>
               </a:rPr>
-              <a:t>What did it actually achieve?"</a:t>
+              <a:t>person, for the right reason?"</a:t>
             </a:r>
             <a:endParaRPr lang="en-US" sz="2300" dirty="0"/>
           </a:p>
@@ -2817,7 +2817,7 @@
                 <a:ea typeface="Aptos" pitchFamily="34" charset="-122"/>
                 <a:cs typeface="Aptos" pitchFamily="34" charset="-120"/>
               </a:rPr>
-              <a:t>The hidden cost of remittance is uncertainty.</a:t>
+              <a:t>Sending money home should not create new worries.</a:t>
             </a:r>
             <a:endParaRPr lang="en-US" sz="2700" dirty="0"/>
           </a:p>
@@ -3060,7 +3060,7 @@
                 <a:ea typeface="Aptos" pitchFamily="34" charset="-122"/>
                 <a:cs typeface="Aptos" pitchFamily="34" charset="-120"/>
               </a:rPr>
-              <a:t>A number can be wrong, changed, or shared. The sender needs confidence before money moves.</a:t>
+              <a:t>A mobile-money number can be wrong, changed, or shared. The sender needs confidence before money moves.</a:t>
             </a:r>
             <a:endParaRPr lang="en-US" sz="1250" dirty="0"/>
           </a:p>
@@ -3198,7 +3198,7 @@
                 <a:ea typeface="Aptos" pitchFamily="34" charset="-122"/>
                 <a:cs typeface="Aptos" pitchFamily="34" charset="-120"/>
               </a:rPr>
-              <a:t>Invisible family outcomes</a:t>
+              <a:t>No clear picture</a:t>
             </a:r>
             <a:endParaRPr lang="en-US" sz="1700" dirty="0"/>
           </a:p>
@@ -3239,7 +3239,7 @@
                 <a:ea typeface="Aptos" pitchFamily="34" charset="-122"/>
                 <a:cs typeface="Aptos" pitchFamily="34" charset="-120"/>
               </a:rPr>
-              <a:t>School fees, rent, land and medicine disappear into a generic transaction history.</a:t>
+              <a:t>The sender needs to know the recipient amount, fee, rate and reason before confirming.</a:t>
             </a:r>
             <a:endParaRPr lang="en-US" sz="1250" dirty="0"/>
           </a:p>
@@ -3377,7 +3377,7 @@
                 <a:ea typeface="Aptos" pitchFamily="34" charset="-122"/>
                 <a:cs typeface="Aptos" pitchFamily="34" charset="-120"/>
               </a:rPr>
-              <a:t>Language and literacy barriers</a:t>
+              <a:t>Hard-to-use apps</a:t>
             </a:r>
             <a:endParaRPr lang="en-US" sz="1700" dirty="0"/>
           </a:p>
@@ -3418,7 +3418,7 @@
                 <a:ea typeface="Aptos" pitchFamily="34" charset="-122"/>
                 <a:cs typeface="Aptos" pitchFamily="34" charset="-120"/>
               </a:rPr>
-              <a:t>Financial English and complex screens exclude users who prefer local languages or voice.</a:t>
+              <a:t>Financial English and complex screens exclude people who prefer local languages or voice.</a:t>
             </a:r>
             <a:endParaRPr lang="en-US" sz="1250" dirty="0"/>
           </a:p>
@@ -3684,7 +3684,7 @@
                 <a:ea typeface="Aptos" pitchFamily="34" charset="-122"/>
                 <a:cs typeface="Aptos" pitchFamily="34" charset="-120"/>
               </a:rPr>
-              <a:t>HomeWard makes family support visible, safer, and easier to understand.</a:t>
+              <a:t>One simple place to check, send, and keep proof.</a:t>
             </a:r>
             <a:endParaRPr lang="en-US" sz="2700" dirty="0"/>
           </a:p>
@@ -3692,7 +3692,48 @@
       </p:sp>
       <p:sp>
         <p:nvSpPr>
-          <p:cNvPr id="4" name="Shape 2"/>
+          <p:cNvPr id="4" name="Text 2"/>
+          <p:cNvSpPr/>
+          <p:nvPr/>
+        </p:nvSpPr>
+        <p:spPr>
+          <a:xfrm>
+            <a:off x="658368" y="1353312"/>
+            <a:ext cx="10332720" cy="310896"/>
+          </a:xfrm>
+          <a:prstGeom prst="rect">
+            <a:avLst/>
+          </a:prstGeom>
+          <a:noFill/>
+          <a:ln/>
+        </p:spPr>
+        <p:txBody>
+          <a:bodyPr wrap="square" lIns="0" tIns="0" rIns="0" bIns="0" rtlCol="0" anchor="ctr">
+            <a:normAutofit/>
+          </a:bodyPr>
+          <a:lstStyle/>
+          <a:p>
+            <a:pPr algn="l" indent="0" marL="0">
+              <a:buNone/>
+            </a:pPr>
+            <a:r>
+              <a:rPr lang="en-US" sz="1250" dirty="0">
+                <a:solidFill>
+                  <a:srgbClr val="60767A"/>
+                </a:solidFill>
+                <a:latin typeface="Aptos" pitchFamily="34" charset="0"/>
+                <a:ea typeface="Aptos" pitchFamily="34" charset="-122"/>
+                <a:cs typeface="Aptos" pitchFamily="34" charset="-120"/>
+              </a:rPr>
+              <a:t>HomeWard is designed for family support, not cryptocurrency experts.</a:t>
+            </a:r>
+            <a:endParaRPr lang="en-US" sz="1250" dirty="0"/>
+          </a:p>
+        </p:txBody>
+      </p:sp>
+      <p:sp>
+        <p:nvSpPr>
+          <p:cNvPr id="5" name="Shape 3"/>
           <p:cNvSpPr/>
           <p:nvPr/>
         </p:nvSpPr>
@@ -3715,7 +3756,7 @@
       </p:sp>
       <p:sp>
         <p:nvSpPr>
-          <p:cNvPr id="5" name="Shape 3"/>
+          <p:cNvPr id="6" name="Shape 4"/>
           <p:cNvSpPr/>
           <p:nvPr/>
         </p:nvSpPr>
@@ -3744,7 +3785,7 @@
       </p:sp>
       <p:sp>
         <p:nvSpPr>
-          <p:cNvPr id="6" name="Shape 4"/>
+          <p:cNvPr id="7" name="Shape 5"/>
           <p:cNvSpPr/>
           <p:nvPr/>
         </p:nvSpPr>
@@ -3773,7 +3814,7 @@
       </p:sp>
       <p:sp>
         <p:nvSpPr>
-          <p:cNvPr id="7" name="Text 5"/>
+          <p:cNvPr id="8" name="Text 6"/>
           <p:cNvSpPr/>
           <p:nvPr/>
         </p:nvSpPr>
@@ -3814,7 +3855,7 @@
       </p:sp>
       <p:sp>
         <p:nvSpPr>
-          <p:cNvPr id="8" name="Text 6"/>
+          <p:cNvPr id="9" name="Text 7"/>
           <p:cNvSpPr/>
           <p:nvPr/>
         </p:nvSpPr>
@@ -3847,7 +3888,7 @@
                 <a:ea typeface="Aptos" pitchFamily="34" charset="-122"/>
                 <a:cs typeface="Aptos" pitchFamily="34" charset="-120"/>
               </a:rPr>
-              <a:t>Trusted Recipient Passport</a:t>
+              <a:t>Check the recipient</a:t>
             </a:r>
             <a:endParaRPr lang="en-US" sz="1550" dirty="0"/>
           </a:p>
@@ -3855,7 +3896,7 @@
       </p:sp>
       <p:sp>
         <p:nvSpPr>
-          <p:cNvPr id="9" name="Text 7"/>
+          <p:cNvPr id="10" name="Text 8"/>
           <p:cNvSpPr/>
           <p:nvPr/>
         </p:nvSpPr>
@@ -3888,7 +3929,7 @@
                 <a:ea typeface="Aptos" pitchFamily="34" charset="-122"/>
                 <a:cs typeface="Aptos" pitchFamily="34" charset="-120"/>
               </a:rPr>
-              <a:t>Full name, phone, network, relationship, history and changed-detail warning.</a:t>
+              <a:t>Save their name, phone, mobile-money network and relationship before sending.</a:t>
             </a:r>
             <a:endParaRPr lang="en-US" sz="1150" dirty="0"/>
           </a:p>
@@ -3896,7 +3937,7 @@
       </p:sp>
       <p:sp>
         <p:nvSpPr>
-          <p:cNvPr id="10" name="Shape 8"/>
+          <p:cNvPr id="11" name="Shape 9"/>
           <p:cNvSpPr/>
           <p:nvPr/>
         </p:nvSpPr>
@@ -3925,7 +3966,7 @@
       </p:sp>
       <p:sp>
         <p:nvSpPr>
-          <p:cNvPr id="11" name="Shape 9"/>
+          <p:cNvPr id="12" name="Shape 10"/>
           <p:cNvSpPr/>
           <p:nvPr/>
         </p:nvSpPr>
@@ -3954,7 +3995,7 @@
       </p:sp>
       <p:sp>
         <p:nvSpPr>
-          <p:cNvPr id="12" name="Text 10"/>
+          <p:cNvPr id="13" name="Text 11"/>
           <p:cNvSpPr/>
           <p:nvPr/>
         </p:nvSpPr>
@@ -3995,7 +4036,7 @@
       </p:sp>
       <p:sp>
         <p:nvSpPr>
-          <p:cNvPr id="13" name="Text 11"/>
+          <p:cNvPr id="14" name="Text 12"/>
           <p:cNvSpPr/>
           <p:nvPr/>
         </p:nvSpPr>
@@ -4028,7 +4069,7 @@
                 <a:ea typeface="Aptos" pitchFamily="34" charset="-122"/>
                 <a:cs typeface="Aptos" pitchFamily="34" charset="-120"/>
               </a:rPr>
-              <a:t>Purpose-led transfer</a:t>
+              <a:t>Know before sending</a:t>
             </a:r>
             <a:endParaRPr lang="en-US" sz="1550" dirty="0"/>
           </a:p>
@@ -4036,7 +4077,7 @@
       </p:sp>
       <p:sp>
         <p:nvSpPr>
-          <p:cNvPr id="14" name="Text 12"/>
+          <p:cNvPr id="15" name="Text 13"/>
           <p:cNvSpPr/>
           <p:nvPr/>
         </p:nvSpPr>
@@ -4069,7 +4110,7 @@
                 <a:ea typeface="Aptos" pitchFamily="34" charset="-122"/>
                 <a:cs typeface="Aptos" pitchFamily="34" charset="-120"/>
               </a:rPr>
-              <a:t>Show the expected UGX, fee, rate and reason before the sender confirms.</a:t>
+              <a:t>See the expected UGX, fee, rate and reason before the sender confirms.</a:t>
             </a:r>
             <a:endParaRPr lang="en-US" sz="1150" dirty="0"/>
           </a:p>
@@ -4077,7 +4118,7 @@
       </p:sp>
       <p:sp>
         <p:nvSpPr>
-          <p:cNvPr id="15" name="Shape 13"/>
+          <p:cNvPr id="16" name="Shape 14"/>
           <p:cNvSpPr/>
           <p:nvPr/>
         </p:nvSpPr>
@@ -4106,7 +4147,7 @@
       </p:sp>
       <p:sp>
         <p:nvSpPr>
-          <p:cNvPr id="16" name="Shape 14"/>
+          <p:cNvPr id="17" name="Shape 15"/>
           <p:cNvSpPr/>
           <p:nvPr/>
         </p:nvSpPr>
@@ -4135,7 +4176,7 @@
       </p:sp>
       <p:sp>
         <p:nvSpPr>
-          <p:cNvPr id="17" name="Text 15"/>
+          <p:cNvPr id="18" name="Text 16"/>
           <p:cNvSpPr/>
           <p:nvPr/>
         </p:nvSpPr>
@@ -4176,7 +4217,7 @@
       </p:sp>
       <p:sp>
         <p:nvSpPr>
-          <p:cNvPr id="18" name="Text 16"/>
+          <p:cNvPr id="19" name="Text 17"/>
           <p:cNvSpPr/>
           <p:nvPr/>
         </p:nvSpPr>
@@ -4209,7 +4250,7 @@
                 <a:ea typeface="Aptos" pitchFamily="34" charset="-122"/>
                 <a:cs typeface="Aptos" pitchFamily="34" charset="-120"/>
               </a:rPr>
-              <a:t>Goals and Circles</a:t>
+              <a:t>Support a real purpose</a:t>
             </a:r>
             <a:endParaRPr lang="en-US" sz="1550" dirty="0"/>
           </a:p>
@@ -4217,7 +4258,7 @@
       </p:sp>
       <p:sp>
         <p:nvSpPr>
-          <p:cNvPr id="19" name="Text 17"/>
+          <p:cNvPr id="20" name="Text 18"/>
           <p:cNvSpPr/>
           <p:nvPr/>
         </p:nvSpPr>
@@ -4258,7 +4299,7 @@
       </p:sp>
       <p:sp>
         <p:nvSpPr>
-          <p:cNvPr id="20" name="Shape 18"/>
+          <p:cNvPr id="21" name="Shape 19"/>
           <p:cNvSpPr/>
           <p:nvPr/>
         </p:nvSpPr>
@@ -4287,7 +4328,7 @@
       </p:sp>
       <p:sp>
         <p:nvSpPr>
-          <p:cNvPr id="21" name="Shape 19"/>
+          <p:cNvPr id="22" name="Shape 20"/>
           <p:cNvSpPr/>
           <p:nvPr/>
         </p:nvSpPr>
@@ -4316,7 +4357,7 @@
       </p:sp>
       <p:sp>
         <p:nvSpPr>
-          <p:cNvPr id="22" name="Text 20"/>
+          <p:cNvPr id="23" name="Text 21"/>
           <p:cNvSpPr/>
           <p:nvPr/>
         </p:nvSpPr>
@@ -4357,7 +4398,7 @@
       </p:sp>
       <p:sp>
         <p:nvSpPr>
-          <p:cNvPr id="23" name="Text 21"/>
+          <p:cNvPr id="24" name="Text 22"/>
           <p:cNvSpPr/>
           <p:nvPr/>
         </p:nvSpPr>
@@ -4390,7 +4431,7 @@
                 <a:ea typeface="Aptos" pitchFamily="34" charset="-122"/>
                 <a:cs typeface="Aptos" pitchFamily="34" charset="-120"/>
               </a:rPr>
-              <a:t>Proof after payment</a:t>
+              <a:t>Keep clear proof</a:t>
             </a:r>
             <a:endParaRPr lang="en-US" sz="1550" dirty="0"/>
           </a:p>
@@ -4398,7 +4439,7 @@
       </p:sp>
       <p:sp>
         <p:nvSpPr>
-          <p:cNvPr id="24" name="Text 22"/>
+          <p:cNvPr id="25" name="Text 23"/>
           <p:cNvSpPr/>
           <p:nvPr/>
         </p:nvSpPr>
@@ -4431,7 +4472,7 @@
                 <a:ea typeface="Aptos" pitchFamily="34" charset="-122"/>
                 <a:cs typeface="Aptos" pitchFamily="34" charset="-120"/>
               </a:rPr>
-              <a:t>Receipt, history, SMS sandbox update and independently verifiable Stellar proof.</a:t>
+              <a:t>A receipt, history, SMS sandbox update and independently verifiable Stellar record.</a:t>
             </a:r>
             <a:endParaRPr lang="en-US" sz="1150" dirty="0"/>
           </a:p>
@@ -4439,7 +4480,7 @@
       </p:sp>
       <p:sp>
         <p:nvSpPr>
-          <p:cNvPr id="25" name="Text 23"/>
+          <p:cNvPr id="26" name="Text 24"/>
           <p:cNvSpPr/>
           <p:nvPr/>
         </p:nvSpPr>
@@ -4480,7 +4521,7 @@
       </p:sp>
       <p:sp>
         <p:nvSpPr>
-          <p:cNvPr id="26" name="Text 24"/>
+          <p:cNvPr id="27" name="Text 25"/>
           <p:cNvSpPr/>
           <p:nvPr/>
         </p:nvSpPr>
@@ -5583,7 +5624,7 @@
                 <a:ea typeface="Aptos" pitchFamily="34" charset="-122"/>
                 <a:cs typeface="Aptos" pitchFamily="34" charset="-120"/>
               </a:rPr>
-              <a:t>HomeWard provisions a user wallet and sends Test USDC on Stellar Testnet.</a:t>
+              <a:t>HomeWard uses Stellar Testnet behind the scenes so the app stays simple for ordinary users.</a:t>
             </a:r>
             <a:endParaRPr lang="en-US" sz="1250" dirty="0"/>
           </a:p>
@@ -5775,7 +5816,7 @@
                 <a:ea typeface="Aptos" pitchFamily="34" charset="-122"/>
                 <a:cs typeface="Aptos" pitchFamily="34" charset="-120"/>
               </a:rPr>
-              <a:t>Each successful transfer exposes its transaction hash and a one-tap Stellar explorer link.</a:t>
+              <a:t>Each successful transfer opens a receipt and a one-tap Stellar explorer record that anyone can inspect.</a:t>
             </a:r>
             <a:endParaRPr lang="en-US" sz="1250" dirty="0"/>
           </a:p>
@@ -5915,7 +5956,7 @@
                 <a:ea typeface="Aptos" pitchFamily="34" charset="-122"/>
                 <a:cs typeface="Aptos" pitchFamily="34" charset="-120"/>
               </a:rPr>
-              <a:t>User wallet</a:t>
+              <a:t>HomeWard wallet</a:t>
             </a:r>
             <a:endParaRPr lang="en-US" sz="1400" dirty="0"/>
           </a:p>
@@ -5956,7 +5997,7 @@
                 <a:ea typeface="Aptos" pitchFamily="34" charset="-122"/>
                 <a:cs typeface="Aptos" pitchFamily="34" charset="-120"/>
               </a:rPr>
-              <a:t>Individual Testnet wallet and USDC trustline</a:t>
+              <a:t>Each signed-in user has an individual Testnet wallet</a:t>
             </a:r>
             <a:endParaRPr lang="en-US" sz="1050" dirty="0"/>
           </a:p>
@@ -6096,7 +6137,7 @@
                 <a:ea typeface="Aptos" pitchFamily="34" charset="-122"/>
                 <a:cs typeface="Aptos" pitchFamily="34" charset="-120"/>
               </a:rPr>
-              <a:t>On-chain transfer</a:t>
+              <a:t>Transfer recorded</a:t>
             </a:r>
             <a:endParaRPr lang="en-US" sz="1400" dirty="0"/>
           </a:p>
@@ -6137,7 +6178,7 @@
                 <a:ea typeface="Aptos" pitchFamily="34" charset="-122"/>
                 <a:cs typeface="Aptos" pitchFamily="34" charset="-120"/>
               </a:rPr>
-              <a:t>Stellar transaction is submitted</a:t>
+              <a:t>Test USDC is sent through Stellar Testnet</a:t>
             </a:r>
             <a:endParaRPr lang="en-US" sz="1050" dirty="0"/>
           </a:p>
@@ -6277,7 +6318,7 @@
                 <a:ea typeface="Aptos" pitchFamily="34" charset="-122"/>
                 <a:cs typeface="Aptos" pitchFamily="34" charset="-120"/>
               </a:rPr>
-              <a:t>Independent receipt</a:t>
+              <a:t>Proof anyone can check</a:t>
             </a:r>
             <a:endParaRPr lang="en-US" sz="1400" dirty="0"/>
           </a:p>
@@ -6318,7 +6359,7 @@
                 <a:ea typeface="Aptos" pitchFamily="34" charset="-122"/>
                 <a:cs typeface="Aptos" pitchFamily="34" charset="-120"/>
               </a:rPr>
-              <a:t>Hash opens in Stellar Expert Testnet</a:t>
+              <a:t>The receipt opens the Stellar Explorer transaction</a:t>
             </a:r>
             <a:endParaRPr lang="en-US" sz="1050" dirty="0"/>
           </a:p>
@@ -8052,7 +8093,7 @@
                 <a:ea typeface="Aptos" pitchFamily="34" charset="-122"/>
                 <a:cs typeface="Aptos" pitchFamily="34" charset="-120"/>
               </a:rPr>
-              <a:t>Known person, relationship, network, history and details-change warning.</a:t>
+              <a:t>Known person, relationship, network, history and changed-detail warning.</a:t>
             </a:r>
             <a:endParaRPr lang="en-US" sz="1150" dirty="0"/>
           </a:p>
@@ -8425,7 +8466,7 @@
                 <a:ea typeface="Aptos" pitchFamily="34" charset="-122"/>
                 <a:cs typeface="Aptos" pitchFamily="34" charset="-120"/>
               </a:rPr>
-              <a:t>Private by default</a:t>
+              <a:t>Private recipient proof</a:t>
             </a:r>
             <a:endParaRPr lang="en-US" sz="1550" dirty="0"/>
           </a:p>
@@ -8466,7 +8507,7 @@
                 <a:ea typeface="Aptos" pitchFamily="34" charset="-122"/>
                 <a:cs typeface="Aptos" pitchFamily="34" charset="-120"/>
               </a:rPr>
-              <a:t>User-scoped wallets, history, recipients, Goals, Circles and chats.</a:t>
+              <a:t>Stellar gets a one-way code, never the recipient’s name or phone number.</a:t>
             </a:r>
             <a:endParaRPr lang="en-US" sz="1150" dirty="0"/>
           </a:p>

</xml_diff>